<commit_message>
deck: live app link + QR on demo slide
</commit_message>
<xml_diff>
--- a/docs/AjoCircle-Mezo-deck.pptx
+++ b/docs/AjoCircle-Mezo-deck.pptx
@@ -922,7 +922,7 @@
           <a:p>
             <a:r>
               <a:rPr lang="en-US" dirty="0"/>
-              <a:t>Links: [live app URL] · github.com/ajocircle-dev/ajocircle · explorer.test.mezo.org</a:t>
+              <a:t>Links: https://ajocircle.pages.dev · github.com/ajocircle-dev/ajocircle · explorer.test.mezo.org</a:t>
             </a:r>
           </a:p>
         </p:txBody>
@@ -8850,8 +8850,9 @@
                 <a:latin typeface="Poppins SemiBold"/>
                 <a:ea typeface="Poppins SemiBold"/>
                 <a:cs typeface="Poppins SemiBold"/>
-              </a:rPr>
-              <a:t>[live app URL]</a:t>
+                <a:hlinkClick r:id="rIdLive"/>
+              </a:rPr>
+              <a:t>https://ajocircle.pages.dev</a:t>
             </a:r>
             <a:r>
               <a:rPr lang="en-US" sz="1600" dirty="0">
@@ -8946,6 +8947,68 @@
           <a:lstStyle/>
           <a:p>
             <a:endParaRPr lang="en-US" dirty="0"/>
+          </a:p>
+        </p:txBody>
+      </p:sp>
+      <p:pic>
+        <p:nvPicPr>
+          <p:cNvPr id="61" name="AC qr live app" descr="QR code: https://ajocircle.pages.dev">
+            <a:hlinkClick r:id="rIdLive"/>
+          </p:cNvPr>
+          <p:cNvPicPr>
+            <a:picLocks noChangeAspect="1"/>
+          </p:cNvPicPr>
+          <p:nvPr/>
+        </p:nvPicPr>
+        <p:blipFill>
+          <a:blip r:embed="rIdQr"/>
+          <a:stretch>
+            <a:fillRect/>
+          </a:stretch>
+        </p:blipFill>
+        <p:spPr>
+          <a:xfrm>
+            <a:off x="13179247" y="5943600"/>
+            <a:ext cx="1188720" cy="1188720"/>
+          </a:xfrm>
+          <a:prstGeom prst="rect">
+            <a:avLst/>
+          </a:prstGeom>
+        </p:spPr>
+      </p:pic>
+      <p:sp>
+        <p:nvSpPr>
+          <p:cNvPr id="62" name="AC qr caption"/>
+          <p:cNvSpPr txBox="1"/>
+          <p:nvPr/>
+        </p:nvSpPr>
+        <p:spPr>
+          <a:xfrm>
+            <a:off x="14505127" y="6263640"/>
+            <a:ext cx="1920240" cy="548640"/>
+          </a:xfrm>
+          <a:prstGeom prst="rect">
+            <a:avLst/>
+          </a:prstGeom>
+          <a:noFill/>
+        </p:spPr>
+        <p:txBody>
+          <a:bodyPr wrap="square" lIns="0" tIns="0" rIns="0" bIns="0" anchor="ctr">
+            <a:noAutofit/>
+          </a:bodyPr>
+          <a:lstStyle/>
+          <a:p>
+            <a:r>
+              <a:rPr lang="en-US" sz="1400" dirty="0">
+                <a:solidFill>
+                  <a:srgbClr val="4D4D4D"/>
+                </a:solidFill>
+                <a:latin typeface="Lato"/>
+                <a:ea typeface="Lato"/>
+                <a:cs typeface="Lato"/>
+              </a:rPr>
+              <a:t>Scan to open the live app</a:t>
+            </a:r>
           </a:p>
         </p:txBody>
       </p:sp>
@@ -12059,7 +12122,7 @@
         <a:srgbClr val="70AD47"/>
       </a:accent6>
       <a:hlink>
-        <a:srgbClr val="0563C1"/>
+        <a:srgbClr val="B85F00"/>
       </a:hlink>
       <a:folHlink>
         <a:srgbClr val="954F72"/>

</xml_diff>